<commit_message>
refactor: update presentation layout geometry and text styling to prevent overlap
</commit_message>
<xml_diff>
--- a/model training project/2nd Presentation 30-9-2026/Medical_Specialty_Classification_Interim_Presentation_2.pptx
+++ b/model training project/2nd Presentation 30-9-2026/Medical_Specialty_Classification_Interim_Presentation_2.pptx
@@ -4685,7 +4685,7 @@
         </p:nvGraphicFramePr>
         <p:xfrm>
           <a:off x="777240" y="1920240"/>
-          <a:ext cx="5760720" cy="3291840"/>
+          <a:ext cx="5760720" cy="3200400"/>
         </p:xfrm>
         <a:graphic>
           <a:graphicData uri="http://schemas.openxmlformats.org/drawingml/2006/table">
@@ -4701,7 +4701,7 @@
                 <a:gridCol w="731520"/>
                 <a:gridCol w="731520"/>
               </a:tblGrid>
-              <a:tr h="470262">
+              <a:tr h="457200">
                 <a:tc>
                   <a:txBody>
                     <a:bodyPr/>
@@ -4847,7 +4847,7 @@
                   </a:tcPr>
                 </a:tc>
               </a:tr>
-              <a:tr h="470262">
+              <a:tr h="457200">
                 <a:tc>
                   <a:txBody>
                     <a:bodyPr/>
@@ -4993,7 +4993,7 @@
                   </a:tcPr>
                 </a:tc>
               </a:tr>
-              <a:tr h="470262">
+              <a:tr h="457200">
                 <a:tc>
                   <a:txBody>
                     <a:bodyPr/>
@@ -5139,7 +5139,7 @@
                   </a:tcPr>
                 </a:tc>
               </a:tr>
-              <a:tr h="470262">
+              <a:tr h="457200">
                 <a:tc>
                   <a:txBody>
                     <a:bodyPr/>
@@ -5261,7 +5261,7 @@
                   <a:tcPr anchor="ctr"/>
                 </a:tc>
               </a:tr>
-              <a:tr h="470262">
+              <a:tr h="457200">
                 <a:tc>
                   <a:txBody>
                     <a:bodyPr/>
@@ -5383,7 +5383,7 @@
                   <a:tcPr anchor="ctr"/>
                 </a:tc>
               </a:tr>
-              <a:tr h="470262">
+              <a:tr h="457200">
                 <a:tc>
                   <a:txBody>
                     <a:bodyPr/>
@@ -5505,7 +5505,7 @@
                   <a:tcPr anchor="ctr"/>
                 </a:tc>
               </a:tr>
-              <a:tr h="470268">
+              <a:tr h="457200">
                 <a:tc>
                   <a:txBody>
                     <a:bodyPr/>
@@ -5639,8 +5639,8 @@
         </p:nvSpPr>
         <p:spPr>
           <a:xfrm>
-            <a:off x="777240" y="5303520"/>
-            <a:ext cx="5760720" cy="777240"/>
+            <a:off x="777240" y="5257800"/>
+            <a:ext cx="5760720" cy="822960"/>
           </a:xfrm>
           <a:prstGeom prst="rect">
             <a:avLst/>
@@ -8432,7 +8432,7 @@
         <p:spPr>
           <a:xfrm>
             <a:off x="548640" y="1371600"/>
-            <a:ext cx="5394960" cy="1078992"/>
+            <a:ext cx="5394960" cy="4846320"/>
           </a:xfrm>
           <a:prstGeom prst="roundRect">
             <a:avLst/>
@@ -8476,8 +8476,8 @@
         </p:nvSpPr>
         <p:spPr>
           <a:xfrm>
-            <a:off x="685800" y="1444752"/>
-            <a:ext cx="5120640" cy="932688"/>
+            <a:off x="777240" y="1554480"/>
+            <a:ext cx="4937760" cy="4480560"/>
           </a:xfrm>
           <a:prstGeom prst="rect">
             <a:avLst/>
@@ -8491,7 +8491,7 @@
           <a:lstStyle/>
           <a:p>
             <a:pPr>
-              <a:defRPr sz="1100" b="1">
+              <a:defRPr sz="1400" b="1">
                 <a:solidFill>
                   <a:srgbClr val="0B1F3A"/>
                 </a:solidFill>
@@ -8499,23 +8499,107 @@
               </a:defRPr>
             </a:pPr>
             <a:r>
-              <a:t>1. Raw 40-Class Formulation Failed</a:t>
+              <a:t>Data, Imbalance &amp; Dimensionality Insights</a:t>
             </a:r>
           </a:p>
           <a:p>
             <a:pPr>
               <a:spcBef>
-                <a:spcPts val="200"/>
+                <a:spcPts val="800"/>
               </a:spcBef>
-              <a:defRPr sz="850">
+              <a:defRPr sz="1000" b="1">
+                <a:solidFill>
+                  <a:srgbClr val="0B1F3A"/>
+                </a:solidFill>
+                <a:latin typeface="Calibri"/>
+              </a:defRPr>
+            </a:pPr>
+            <a:r>
+              <a:t>• 1. Raw 40-Class Formulation Failed:</a:t>
+            </a:r>
+            <a:br/>
+            <a:r>
+              <a:rPr b="0">
                 <a:solidFill>
                   <a:srgbClr val="1E293B"/>
                 </a:solidFill>
-                <a:latin typeface="Calibri"/>
-              </a:defRPr>
-            </a:pPr>
-            <a:r>
-              <a:t>• Initial 40-class training produced 7.85% to 27.39% accuracy, demonstrating that the raw dataset was unsuitable without domain refinement.</a:t>
+              </a:rPr>
+              <a:t>Initial 40-class training produced 7.85% to 27.39% accuracy, demonstrating that the raw dataset was unsuitable without domain refinement.</a:t>
+            </a:r>
+          </a:p>
+          <a:p>
+            <a:pPr>
+              <a:spcBef>
+                <a:spcPts val="800"/>
+              </a:spcBef>
+              <a:defRPr sz="1000" b="1">
+                <a:solidFill>
+                  <a:srgbClr val="0B1F3A"/>
+                </a:solidFill>
+                <a:latin typeface="Calibri"/>
+              </a:defRPr>
+            </a:pPr>
+            <a:r>
+              <a:t>• 2. Severe Class Imbalance Distorted Learning:</a:t>
+            </a:r>
+            <a:br/>
+            <a:r>
+              <a:rPr b="0">
+                <a:solidFill>
+                  <a:srgbClr val="1E293B"/>
+                </a:solidFill>
+              </a:rPr>
+              <a:t>Extreme 184:1 skew starved minority classes; unweighted models predicted majority 'Surgery' trivially. Class weighting and SMOTE restored balanced gradients.</a:t>
+            </a:r>
+          </a:p>
+          <a:p>
+            <a:pPr>
+              <a:spcBef>
+                <a:spcPts val="800"/>
+              </a:spcBef>
+              <a:defRPr sz="1000" b="1">
+                <a:solidFill>
+                  <a:srgbClr val="0B1F3A"/>
+                </a:solidFill>
+                <a:latin typeface="Calibri"/>
+              </a:defRPr>
+            </a:pPr>
+            <a:r>
+              <a:t>• 3. 310,000-Feature TF-IDF Created Sparsity Trap:</a:t>
+            </a:r>
+            <a:br/>
+            <a:r>
+              <a:rPr b="0">
+                <a:solidFill>
+                  <a:srgbClr val="1E293B"/>
+                </a:solidFill>
+              </a:rPr>
+              <a:t>Unconstrained TF-IDF severely overfitted (78:1 feature-to-sample ratio). Restricting to 8,000 features with sublinear scaling stabilized feature space.</a:t>
+            </a:r>
+          </a:p>
+          <a:p>
+            <a:pPr>
+              <a:spcBef>
+                <a:spcPts val="800"/>
+              </a:spcBef>
+              <a:defRPr sz="1000" b="1">
+                <a:solidFill>
+                  <a:srgbClr val="0B1F3A"/>
+                </a:solidFill>
+                <a:latin typeface="Calibri"/>
+              </a:defRPr>
+            </a:pPr>
+            <a:r>
+              <a:t>• 4. Pruning Document Formats Cleared Noise:</a:t>
+            </a:r>
+            <a:br/>
+            <a:r>
+              <a:rPr b="0">
+                <a:solidFill>
+                  <a:srgbClr val="1E293B"/>
+                </a:solidFill>
+              </a:rPr>
+              <a:t>Removing administrative formats (SOAP notes, consults, discharge summaries) eliminated non-specialty linguistic overlap.</a:t>
             </a:r>
           </a:p>
         </p:txBody>
@@ -8529,7 +8613,7 @@
         <p:spPr>
           <a:xfrm>
             <a:off x="6217920" y="1371600"/>
-            <a:ext cx="5394960" cy="1078992"/>
+            <a:ext cx="5422392" cy="4846320"/>
           </a:xfrm>
           <a:prstGeom prst="roundRect">
             <a:avLst/>
@@ -8573,8 +8657,8 @@
         </p:nvSpPr>
         <p:spPr>
           <a:xfrm>
-            <a:off x="6355080" y="1444752"/>
-            <a:ext cx="5120640" cy="932688"/>
+            <a:off x="6446520" y="1554480"/>
+            <a:ext cx="4965192" cy="4480560"/>
           </a:xfrm>
           <a:prstGeom prst="rect">
             <a:avLst/>
@@ -8588,613 +8672,115 @@
           <a:lstStyle/>
           <a:p>
             <a:pPr>
-              <a:defRPr sz="1100" b="1">
-                <a:solidFill>
-                  <a:srgbClr val="0B1F3A"/>
+              <a:defRPr sz="1400" b="1">
+                <a:solidFill>
+                  <a:srgbClr val="0D9488"/>
                 </a:solidFill>
                 <a:latin typeface="Cambria"/>
               </a:defRPr>
             </a:pPr>
             <a:r>
-              <a:t>2. Severe Class Imbalance Distorted Learning</a:t>
+              <a:t>Model Performance &amp; Engineering Insights</a:t>
             </a:r>
           </a:p>
           <a:p>
             <a:pPr>
               <a:spcBef>
-                <a:spcPts val="200"/>
+                <a:spcPts val="800"/>
               </a:spcBef>
-              <a:defRPr sz="850">
+              <a:defRPr sz="1000" b="1">
+                <a:solidFill>
+                  <a:srgbClr val="0D9488"/>
+                </a:solidFill>
+                <a:latin typeface="Calibri"/>
+              </a:defRPr>
+            </a:pPr>
+            <a:r>
+              <a:t>✓ 5. Final 8-Specialty Dataset Achieved 77%–89%:</a:t>
+            </a:r>
+            <a:br/>
+            <a:r>
+              <a:rPr b="0">
                 <a:solidFill>
                   <a:srgbClr val="1E293B"/>
                 </a:solidFill>
-                <a:latin typeface="Calibri"/>
-              </a:defRPr>
-            </a:pPr>
-            <a:r>
-              <a:t>• Extreme 184:1 skew starved minority classes; unweighted models predicted majority 'Surgery' trivially. Class weighting and SMOTE restored balanced gradients.</a:t>
-            </a:r>
-          </a:p>
-        </p:txBody>
-      </p:sp>
-      <p:sp>
-        <p:nvSpPr>
-          <p:cNvPr id="12" name="Rounded Rectangle 11"/>
-          <p:cNvSpPr/>
-          <p:nvPr/>
-        </p:nvSpPr>
-        <p:spPr>
-          <a:xfrm>
-            <a:off x="548640" y="2606040"/>
-            <a:ext cx="5394960" cy="1078992"/>
-          </a:xfrm>
-          <a:prstGeom prst="roundRect">
-            <a:avLst/>
-          </a:prstGeom>
-          <a:solidFill>
-            <a:srgbClr val="FFFFFF"/>
-          </a:solidFill>
-          <a:ln w="12700">
-            <a:solidFill>
-              <a:srgbClr val="DCE2EC"/>
-            </a:solidFill>
-          </a:ln>
-        </p:spPr>
-        <p:style>
-          <a:lnRef idx="1">
-            <a:schemeClr val="accent1"/>
-          </a:lnRef>
-          <a:fillRef idx="3">
-            <a:schemeClr val="accent1"/>
-          </a:fillRef>
-          <a:effectRef idx="2">
-            <a:schemeClr val="accent1"/>
-          </a:effectRef>
-          <a:fontRef idx="minor">
-            <a:schemeClr val="lt1"/>
-          </a:fontRef>
-        </p:style>
-        <p:txBody>
-          <a:bodyPr rtlCol="0" anchor="ctr"/>
-          <a:lstStyle/>
-          <a:p>
-            <a:pPr algn="ctr"/>
-          </a:p>
-        </p:txBody>
-      </p:sp>
-      <p:sp>
-        <p:nvSpPr>
-          <p:cNvPr id="13" name="TextBox 12"/>
-          <p:cNvSpPr txBox="1"/>
-          <p:nvPr/>
-        </p:nvSpPr>
-        <p:spPr>
-          <a:xfrm>
-            <a:off x="685800" y="2679192"/>
-            <a:ext cx="5120640" cy="932688"/>
-          </a:xfrm>
-          <a:prstGeom prst="rect">
-            <a:avLst/>
-          </a:prstGeom>
-          <a:noFill/>
-        </p:spPr>
-        <p:txBody>
-          <a:bodyPr wrap="square">
-            <a:spAutoFit/>
-          </a:bodyPr>
-          <a:lstStyle/>
-          <a:p>
-            <a:pPr>
-              <a:defRPr sz="1100" b="1">
-                <a:solidFill>
-                  <a:srgbClr val="0B1F3A"/>
-                </a:solidFill>
-                <a:latin typeface="Cambria"/>
-              </a:defRPr>
-            </a:pPr>
-            <a:r>
-              <a:t>3. 310,000-Feature TF-IDF Created Sparsity Trap</a:t>
+              </a:rPr>
+              <a:t>Focusing on 8 mutually exclusive clinical departments dramatically elevated performance across all 4 machine-learning algorithms.</a:t>
             </a:r>
           </a:p>
           <a:p>
             <a:pPr>
               <a:spcBef>
-                <a:spcPts val="200"/>
+                <a:spcPts val="800"/>
               </a:spcBef>
-              <a:defRPr sz="850">
+              <a:defRPr sz="1000" b="1">
+                <a:solidFill>
+                  <a:srgbClr val="0D9488"/>
+                </a:solidFill>
+                <a:latin typeface="Calibri"/>
+              </a:defRPr>
+            </a:pPr>
+            <a:r>
+              <a:t>✓ 6. Linear SVM Delivered Top Individual Accuracy:</a:t>
+            </a:r>
+            <a:br/>
+            <a:r>
+              <a:rPr b="0">
                 <a:solidFill>
                   <a:srgbClr val="1E293B"/>
                 </a:solidFill>
-                <a:latin typeface="Calibri"/>
-              </a:defRPr>
-            </a:pPr>
-            <a:r>
-              <a:t>• Unconstrained TF-IDF severely overfitted (78:1 feature-to-sample ratio). Restricting to 8,000 features with sublinear scaling stabilized feature space.</a:t>
-            </a:r>
-          </a:p>
-        </p:txBody>
-      </p:sp>
-      <p:sp>
-        <p:nvSpPr>
-          <p:cNvPr id="14" name="Rounded Rectangle 13"/>
-          <p:cNvSpPr/>
-          <p:nvPr/>
-        </p:nvSpPr>
-        <p:spPr>
-          <a:xfrm>
-            <a:off x="6217920" y="2606040"/>
-            <a:ext cx="5394960" cy="1078992"/>
-          </a:xfrm>
-          <a:prstGeom prst="roundRect">
-            <a:avLst/>
-          </a:prstGeom>
-          <a:solidFill>
-            <a:srgbClr val="FFFFFF"/>
-          </a:solidFill>
-          <a:ln w="12700">
-            <a:solidFill>
-              <a:srgbClr val="DCE2EC"/>
-            </a:solidFill>
-          </a:ln>
-        </p:spPr>
-        <p:style>
-          <a:lnRef idx="1">
-            <a:schemeClr val="accent1"/>
-          </a:lnRef>
-          <a:fillRef idx="3">
-            <a:schemeClr val="accent1"/>
-          </a:fillRef>
-          <a:effectRef idx="2">
-            <a:schemeClr val="accent1"/>
-          </a:effectRef>
-          <a:fontRef idx="minor">
-            <a:schemeClr val="lt1"/>
-          </a:fontRef>
-        </p:style>
-        <p:txBody>
-          <a:bodyPr rtlCol="0" anchor="ctr"/>
-          <a:lstStyle/>
-          <a:p>
-            <a:pPr algn="ctr"/>
-          </a:p>
-        </p:txBody>
-      </p:sp>
-      <p:sp>
-        <p:nvSpPr>
-          <p:cNvPr id="15" name="TextBox 14"/>
-          <p:cNvSpPr txBox="1"/>
-          <p:nvPr/>
-        </p:nvSpPr>
-        <p:spPr>
-          <a:xfrm>
-            <a:off x="6355080" y="2679192"/>
-            <a:ext cx="5120640" cy="932688"/>
-          </a:xfrm>
-          <a:prstGeom prst="rect">
-            <a:avLst/>
-          </a:prstGeom>
-          <a:noFill/>
-        </p:spPr>
-        <p:txBody>
-          <a:bodyPr wrap="square">
-            <a:spAutoFit/>
-          </a:bodyPr>
-          <a:lstStyle/>
-          <a:p>
-            <a:pPr>
-              <a:defRPr sz="1100" b="1">
-                <a:solidFill>
-                  <a:srgbClr val="0B1F3A"/>
-                </a:solidFill>
-                <a:latin typeface="Cambria"/>
-              </a:defRPr>
-            </a:pPr>
-            <a:r>
-              <a:t>4. Pruning Document Formats Cleared Noise</a:t>
+              </a:rPr>
+              <a:t>Linear SVM achieved 88.59% accuracy and 0.8971 Macro F1, outperforming Random Forest by &gt; 6.6% due to optimal high-dimensional text separation.</a:t>
             </a:r>
           </a:p>
           <a:p>
             <a:pPr>
               <a:spcBef>
-                <a:spcPts val="200"/>
+                <a:spcPts val="800"/>
               </a:spcBef>
-              <a:defRPr sz="850">
+              <a:defRPr sz="1000" b="1">
+                <a:solidFill>
+                  <a:srgbClr val="0D9488"/>
+                </a:solidFill>
+                <a:latin typeface="Calibri"/>
+              </a:defRPr>
+            </a:pPr>
+            <a:r>
+              <a:t>✓ 7. Soft Voting Produced Robust Generalization:</a:t>
+            </a:r>
+            <a:br/>
+            <a:r>
+              <a:rPr b="0">
                 <a:solidFill>
                   <a:srgbClr val="1E293B"/>
                 </a:solidFill>
-                <a:latin typeface="Calibri"/>
-              </a:defRPr>
-            </a:pPr>
-            <a:r>
-              <a:t>• Removing administrative formats (SOAP notes, consults, discharge summaries) eliminated non-specialty linguistic overlap.</a:t>
-            </a:r>
-          </a:p>
-        </p:txBody>
-      </p:sp>
-      <p:sp>
-        <p:nvSpPr>
-          <p:cNvPr id="16" name="Rounded Rectangle 15"/>
-          <p:cNvSpPr/>
-          <p:nvPr/>
-        </p:nvSpPr>
-        <p:spPr>
-          <a:xfrm>
-            <a:off x="548640" y="3840480"/>
-            <a:ext cx="5394960" cy="1078992"/>
-          </a:xfrm>
-          <a:prstGeom prst="roundRect">
-            <a:avLst/>
-          </a:prstGeom>
-          <a:solidFill>
-            <a:srgbClr val="FFFFFF"/>
-          </a:solidFill>
-          <a:ln w="12700">
-            <a:solidFill>
-              <a:srgbClr val="DCE2EC"/>
-            </a:solidFill>
-          </a:ln>
-        </p:spPr>
-        <p:style>
-          <a:lnRef idx="1">
-            <a:schemeClr val="accent1"/>
-          </a:lnRef>
-          <a:fillRef idx="3">
-            <a:schemeClr val="accent1"/>
-          </a:fillRef>
-          <a:effectRef idx="2">
-            <a:schemeClr val="accent1"/>
-          </a:effectRef>
-          <a:fontRef idx="minor">
-            <a:schemeClr val="lt1"/>
-          </a:fontRef>
-        </p:style>
-        <p:txBody>
-          <a:bodyPr rtlCol="0" anchor="ctr"/>
-          <a:lstStyle/>
-          <a:p>
-            <a:pPr algn="ctr"/>
-          </a:p>
-        </p:txBody>
-      </p:sp>
-      <p:sp>
-        <p:nvSpPr>
-          <p:cNvPr id="17" name="TextBox 16"/>
-          <p:cNvSpPr txBox="1"/>
-          <p:nvPr/>
-        </p:nvSpPr>
-        <p:spPr>
-          <a:xfrm>
-            <a:off x="685800" y="3913632"/>
-            <a:ext cx="5120640" cy="932688"/>
-          </a:xfrm>
-          <a:prstGeom prst="rect">
-            <a:avLst/>
-          </a:prstGeom>
-          <a:noFill/>
-        </p:spPr>
-        <p:txBody>
-          <a:bodyPr wrap="square">
-            <a:spAutoFit/>
-          </a:bodyPr>
-          <a:lstStyle/>
-          <a:p>
-            <a:pPr>
-              <a:defRPr sz="1100" b="1">
-                <a:solidFill>
-                  <a:srgbClr val="0B1F3A"/>
-                </a:solidFill>
-                <a:latin typeface="Cambria"/>
-              </a:defRPr>
-            </a:pPr>
-            <a:r>
-              <a:t>5. Final 8-Specialty Dataset Achieved 77%–89%</a:t>
+              </a:rPr>
+              <a:t>Weighted probability consensus (2:2:1:1) achieved 87.99% accuracy and 0.8898 Macro F1, providing smooth confidence calibration.</a:t>
             </a:r>
           </a:p>
           <a:p>
             <a:pPr>
               <a:spcBef>
-                <a:spcPts val="200"/>
+                <a:spcPts val="800"/>
               </a:spcBef>
-              <a:defRPr sz="850">
+              <a:defRPr sz="1000" b="1">
+                <a:solidFill>
+                  <a:srgbClr val="0D9488"/>
+                </a:solidFill>
+                <a:latin typeface="Calibri"/>
+              </a:defRPr>
+            </a:pPr>
+            <a:r>
+              <a:t>✓ 8. Controlled TF-IDF Reduced Dimensionality:</a:t>
+            </a:r>
+            <a:br/>
+            <a:r>
+              <a:rPr b="0">
                 <a:solidFill>
                   <a:srgbClr val="1E293B"/>
                 </a:solidFill>
-                <a:latin typeface="Calibri"/>
-              </a:defRPr>
-            </a:pPr>
-            <a:r>
-              <a:t>• Focusing on 8 mutually exclusive clinical departments dramatically elevated performance across all 4 machine-learning algorithms.</a:t>
-            </a:r>
-          </a:p>
-        </p:txBody>
-      </p:sp>
-      <p:sp>
-        <p:nvSpPr>
-          <p:cNvPr id="18" name="Rounded Rectangle 17"/>
-          <p:cNvSpPr/>
-          <p:nvPr/>
-        </p:nvSpPr>
-        <p:spPr>
-          <a:xfrm>
-            <a:off x="6217920" y="3840480"/>
-            <a:ext cx="5394960" cy="1078992"/>
-          </a:xfrm>
-          <a:prstGeom prst="roundRect">
-            <a:avLst/>
-          </a:prstGeom>
-          <a:solidFill>
-            <a:srgbClr val="FFFFFF"/>
-          </a:solidFill>
-          <a:ln w="12700">
-            <a:solidFill>
-              <a:srgbClr val="DCE2EC"/>
-            </a:solidFill>
-          </a:ln>
-        </p:spPr>
-        <p:style>
-          <a:lnRef idx="1">
-            <a:schemeClr val="accent1"/>
-          </a:lnRef>
-          <a:fillRef idx="3">
-            <a:schemeClr val="accent1"/>
-          </a:fillRef>
-          <a:effectRef idx="2">
-            <a:schemeClr val="accent1"/>
-          </a:effectRef>
-          <a:fontRef idx="minor">
-            <a:schemeClr val="lt1"/>
-          </a:fontRef>
-        </p:style>
-        <p:txBody>
-          <a:bodyPr rtlCol="0" anchor="ctr"/>
-          <a:lstStyle/>
-          <a:p>
-            <a:pPr algn="ctr"/>
-          </a:p>
-        </p:txBody>
-      </p:sp>
-      <p:sp>
-        <p:nvSpPr>
-          <p:cNvPr id="19" name="TextBox 18"/>
-          <p:cNvSpPr txBox="1"/>
-          <p:nvPr/>
-        </p:nvSpPr>
-        <p:spPr>
-          <a:xfrm>
-            <a:off x="6355080" y="3913632"/>
-            <a:ext cx="5120640" cy="932688"/>
-          </a:xfrm>
-          <a:prstGeom prst="rect">
-            <a:avLst/>
-          </a:prstGeom>
-          <a:noFill/>
-        </p:spPr>
-        <p:txBody>
-          <a:bodyPr wrap="square">
-            <a:spAutoFit/>
-          </a:bodyPr>
-          <a:lstStyle/>
-          <a:p>
-            <a:pPr>
-              <a:defRPr sz="1100" b="1">
-                <a:solidFill>
-                  <a:srgbClr val="0B1F3A"/>
-                </a:solidFill>
-                <a:latin typeface="Cambria"/>
-              </a:defRPr>
-            </a:pPr>
-            <a:r>
-              <a:t>6. Linear SVM Delivered Top Individual Accuracy</a:t>
-            </a:r>
-          </a:p>
-          <a:p>
-            <a:pPr>
-              <a:spcBef>
-                <a:spcPts val="200"/>
-              </a:spcBef>
-              <a:defRPr sz="850">
-                <a:solidFill>
-                  <a:srgbClr val="1E293B"/>
-                </a:solidFill>
-                <a:latin typeface="Calibri"/>
-              </a:defRPr>
-            </a:pPr>
-            <a:r>
-              <a:t>• Linear SVM achieved 88.59% accuracy and 0.8971 Macro F1, outperforming Random Forest by &gt; 6.6% due to optimal high-dimensional text separation.</a:t>
-            </a:r>
-          </a:p>
-        </p:txBody>
-      </p:sp>
-      <p:sp>
-        <p:nvSpPr>
-          <p:cNvPr id="20" name="Rounded Rectangle 19"/>
-          <p:cNvSpPr/>
-          <p:nvPr/>
-        </p:nvSpPr>
-        <p:spPr>
-          <a:xfrm>
-            <a:off x="548640" y="5074920"/>
-            <a:ext cx="5394960" cy="1078992"/>
-          </a:xfrm>
-          <a:prstGeom prst="roundRect">
-            <a:avLst/>
-          </a:prstGeom>
-          <a:solidFill>
-            <a:srgbClr val="FFFFFF"/>
-          </a:solidFill>
-          <a:ln w="12700">
-            <a:solidFill>
-              <a:srgbClr val="DCE2EC"/>
-            </a:solidFill>
-          </a:ln>
-        </p:spPr>
-        <p:style>
-          <a:lnRef idx="1">
-            <a:schemeClr val="accent1"/>
-          </a:lnRef>
-          <a:fillRef idx="3">
-            <a:schemeClr val="accent1"/>
-          </a:fillRef>
-          <a:effectRef idx="2">
-            <a:schemeClr val="accent1"/>
-          </a:effectRef>
-          <a:fontRef idx="minor">
-            <a:schemeClr val="lt1"/>
-          </a:fontRef>
-        </p:style>
-        <p:txBody>
-          <a:bodyPr rtlCol="0" anchor="ctr"/>
-          <a:lstStyle/>
-          <a:p>
-            <a:pPr algn="ctr"/>
-          </a:p>
-        </p:txBody>
-      </p:sp>
-      <p:sp>
-        <p:nvSpPr>
-          <p:cNvPr id="21" name="TextBox 20"/>
-          <p:cNvSpPr txBox="1"/>
-          <p:nvPr/>
-        </p:nvSpPr>
-        <p:spPr>
-          <a:xfrm>
-            <a:off x="685800" y="5148072"/>
-            <a:ext cx="5120640" cy="932688"/>
-          </a:xfrm>
-          <a:prstGeom prst="rect">
-            <a:avLst/>
-          </a:prstGeom>
-          <a:noFill/>
-        </p:spPr>
-        <p:txBody>
-          <a:bodyPr wrap="square">
-            <a:spAutoFit/>
-          </a:bodyPr>
-          <a:lstStyle/>
-          <a:p>
-            <a:pPr>
-              <a:defRPr sz="1100" b="1">
-                <a:solidFill>
-                  <a:srgbClr val="0B1F3A"/>
-                </a:solidFill>
-                <a:latin typeface="Cambria"/>
-              </a:defRPr>
-            </a:pPr>
-            <a:r>
-              <a:t>7. Soft Voting Produced Robust Ensemble Generalization</a:t>
-            </a:r>
-          </a:p>
-          <a:p>
-            <a:pPr>
-              <a:spcBef>
-                <a:spcPts val="200"/>
-              </a:spcBef>
-              <a:defRPr sz="850">
-                <a:solidFill>
-                  <a:srgbClr val="1E293B"/>
-                </a:solidFill>
-                <a:latin typeface="Calibri"/>
-              </a:defRPr>
-            </a:pPr>
-            <a:r>
-              <a:t>• Weighted probability consensus (2:2:1:1) achieved 87.99% accuracy and 0.8898 Macro F1, providing smooth confidence calibration.</a:t>
-            </a:r>
-          </a:p>
-        </p:txBody>
-      </p:sp>
-      <p:sp>
-        <p:nvSpPr>
-          <p:cNvPr id="22" name="Rounded Rectangle 21"/>
-          <p:cNvSpPr/>
-          <p:nvPr/>
-        </p:nvSpPr>
-        <p:spPr>
-          <a:xfrm>
-            <a:off x="6217920" y="5074920"/>
-            <a:ext cx="5394960" cy="1078992"/>
-          </a:xfrm>
-          <a:prstGeom prst="roundRect">
-            <a:avLst/>
-          </a:prstGeom>
-          <a:solidFill>
-            <a:srgbClr val="FFFFFF"/>
-          </a:solidFill>
-          <a:ln w="12700">
-            <a:solidFill>
-              <a:srgbClr val="DCE2EC"/>
-            </a:solidFill>
-          </a:ln>
-        </p:spPr>
-        <p:style>
-          <a:lnRef idx="1">
-            <a:schemeClr val="accent1"/>
-          </a:lnRef>
-          <a:fillRef idx="3">
-            <a:schemeClr val="accent1"/>
-          </a:fillRef>
-          <a:effectRef idx="2">
-            <a:schemeClr val="accent1"/>
-          </a:effectRef>
-          <a:fontRef idx="minor">
-            <a:schemeClr val="lt1"/>
-          </a:fontRef>
-        </p:style>
-        <p:txBody>
-          <a:bodyPr rtlCol="0" anchor="ctr"/>
-          <a:lstStyle/>
-          <a:p>
-            <a:pPr algn="ctr"/>
-          </a:p>
-        </p:txBody>
-      </p:sp>
-      <p:sp>
-        <p:nvSpPr>
-          <p:cNvPr id="23" name="TextBox 22"/>
-          <p:cNvSpPr txBox="1"/>
-          <p:nvPr/>
-        </p:nvSpPr>
-        <p:spPr>
-          <a:xfrm>
-            <a:off x="6355080" y="5148072"/>
-            <a:ext cx="5120640" cy="932688"/>
-          </a:xfrm>
-          <a:prstGeom prst="rect">
-            <a:avLst/>
-          </a:prstGeom>
-          <a:noFill/>
-        </p:spPr>
-        <p:txBody>
-          <a:bodyPr wrap="square">
-            <a:spAutoFit/>
-          </a:bodyPr>
-          <a:lstStyle/>
-          <a:p>
-            <a:pPr>
-              <a:defRPr sz="1100" b="1">
-                <a:solidFill>
-                  <a:srgbClr val="0B1F3A"/>
-                </a:solidFill>
-                <a:latin typeface="Cambria"/>
-              </a:defRPr>
-            </a:pPr>
-            <a:r>
-              <a:t>8. Controlled TF-IDF Drastically Reduced Dimensionality</a:t>
-            </a:r>
-          </a:p>
-          <a:p>
-            <a:pPr>
-              <a:spcBef>
-                <a:spcPts val="200"/>
-              </a:spcBef>
-              <a:defRPr sz="850">
-                <a:solidFill>
-                  <a:srgbClr val="1E293B"/>
-                </a:solidFill>
-                <a:latin typeface="Calibri"/>
-              </a:defRPr>
-            </a:pPr>
-            <a:r>
-              <a:t>• 8,000 features with sublinear TF scaling provided compact, highly discriminative vectors yielding sub-15ms CPU inference.</a:t>
+              </a:rPr>
+              <a:t>8,000 features with sublinear TF scaling provided compact, highly discriminative vectors yielding sub-15ms CPU inference.</a:t>
             </a:r>
           </a:p>
         </p:txBody>
@@ -9549,7 +9135,7 @@
               <a:spcBef>
                 <a:spcPts val="300"/>
               </a:spcBef>
-              <a:defRPr sz="900" b="1">
+              <a:defRPr sz="850" b="1">
                 <a:solidFill>
                   <a:srgbClr val="0B1F3A"/>
                 </a:solidFill>
@@ -9573,7 +9159,7 @@
               <a:spcBef>
                 <a:spcPts val="300"/>
               </a:spcBef>
-              <a:defRPr sz="900" b="1">
+              <a:defRPr sz="850" b="1">
                 <a:solidFill>
                   <a:srgbClr val="0B1F3A"/>
                 </a:solidFill>
@@ -9597,7 +9183,7 @@
               <a:spcBef>
                 <a:spcPts val="300"/>
               </a:spcBef>
-              <a:defRPr sz="900" b="1">
+              <a:defRPr sz="850" b="1">
                 <a:solidFill>
                   <a:srgbClr val="0B1F3A"/>
                 </a:solidFill>
@@ -9621,7 +9207,7 @@
               <a:spcBef>
                 <a:spcPts val="300"/>
               </a:spcBef>
-              <a:defRPr sz="900" b="1">
+              <a:defRPr sz="850" b="1">
                 <a:solidFill>
                   <a:srgbClr val="0B1F3A"/>
                 </a:solidFill>
@@ -9645,7 +9231,7 @@
               <a:spcBef>
                 <a:spcPts val="300"/>
               </a:spcBef>
-              <a:defRPr sz="900" b="1">
+              <a:defRPr sz="850" b="1">
                 <a:solidFill>
                   <a:srgbClr val="0B1F3A"/>
                 </a:solidFill>
@@ -9669,7 +9255,7 @@
               <a:spcBef>
                 <a:spcPts val="300"/>
               </a:spcBef>
-              <a:defRPr sz="900" b="1">
+              <a:defRPr sz="850" b="1">
                 <a:solidFill>
                   <a:srgbClr val="0B1F3A"/>
                 </a:solidFill>
@@ -9693,7 +9279,7 @@
               <a:spcBef>
                 <a:spcPts val="300"/>
               </a:spcBef>
-              <a:defRPr sz="900" b="1">
+              <a:defRPr sz="850" b="1">
                 <a:solidFill>
                   <a:srgbClr val="0B1F3A"/>
                 </a:solidFill>
@@ -9717,7 +9303,7 @@
               <a:spcBef>
                 <a:spcPts val="300"/>
               </a:spcBef>
-              <a:defRPr sz="900" b="1">
+              <a:defRPr sz="850" b="1">
                 <a:solidFill>
                   <a:srgbClr val="0B1F3A"/>
                 </a:solidFill>
@@ -9741,7 +9327,7 @@
               <a:spcBef>
                 <a:spcPts val="300"/>
               </a:spcBef>
-              <a:defRPr sz="900" b="1">
+              <a:defRPr sz="850" b="1">
                 <a:solidFill>
                   <a:srgbClr val="0B1F3A"/>
                 </a:solidFill>
@@ -9765,7 +9351,7 @@
               <a:spcBef>
                 <a:spcPts val="300"/>
               </a:spcBef>
-              <a:defRPr sz="900" b="1">
+              <a:defRPr sz="850" b="1">
                 <a:solidFill>
                   <a:srgbClr val="0B1F3A"/>
                 </a:solidFill>
@@ -9789,7 +9375,7 @@
               <a:spcBef>
                 <a:spcPts val="300"/>
               </a:spcBef>
-              <a:defRPr sz="900" b="1">
+              <a:defRPr sz="850" b="1">
                 <a:solidFill>
                   <a:srgbClr val="0B1F3A"/>
                 </a:solidFill>
@@ -9894,7 +9480,7 @@
               <a:spcBef>
                 <a:spcPts val="600"/>
               </a:spcBef>
-              <a:defRPr sz="1000" b="1">
+              <a:defRPr sz="950" b="1">
                 <a:solidFill>
                   <a:srgbClr val="2563EB"/>
                 </a:solidFill>
@@ -9919,7 +9505,7 @@
               <a:spcBef>
                 <a:spcPts val="600"/>
               </a:spcBef>
-              <a:defRPr sz="1000" b="1">
+              <a:defRPr sz="950" b="1">
                 <a:solidFill>
                   <a:srgbClr val="2563EB"/>
                 </a:solidFill>
@@ -9944,7 +9530,7 @@
               <a:spcBef>
                 <a:spcPts val="600"/>
               </a:spcBef>
-              <a:defRPr sz="1000" b="1">
+              <a:defRPr sz="950" b="1">
                 <a:solidFill>
                   <a:srgbClr val="2563EB"/>
                 </a:solidFill>
@@ -9969,7 +9555,7 @@
               <a:spcBef>
                 <a:spcPts val="600"/>
               </a:spcBef>
-              <a:defRPr sz="1000" b="1">
+              <a:defRPr sz="950" b="1">
                 <a:solidFill>
                   <a:srgbClr val="2563EB"/>
                 </a:solidFill>
@@ -9994,7 +9580,7 @@
               <a:spcBef>
                 <a:spcPts val="600"/>
               </a:spcBef>
-              <a:defRPr sz="1000" b="1">
+              <a:defRPr sz="950" b="1">
                 <a:solidFill>
                   <a:srgbClr val="2563EB"/>
                 </a:solidFill>
@@ -10019,7 +9605,7 @@
               <a:spcBef>
                 <a:spcPts val="600"/>
               </a:spcBef>
-              <a:defRPr sz="1000" b="1">
+              <a:defRPr sz="950" b="1">
                 <a:solidFill>
                   <a:srgbClr val="2563EB"/>
                 </a:solidFill>
@@ -10660,7 +10246,7 @@
           <a:lstStyle/>
           <a:p>
             <a:pPr algn="ctr">
-              <a:defRPr sz="1200" b="1">
+              <a:defRPr sz="1150" b="1">
                 <a:solidFill>
                   <a:srgbClr val="0B1F3A"/>
                 </a:solidFill>
@@ -10755,9 +10341,9 @@
           <a:p>
             <a:pPr>
               <a:spcBef>
-                <a:spcPts val="600"/>
+                <a:spcPts val="500"/>
               </a:spcBef>
-              <a:defRPr sz="1050" b="1">
+              <a:defRPr sz="1000" b="1">
                 <a:solidFill>
                   <a:srgbClr val="0B1F3A"/>
                 </a:solidFill>
@@ -10779,9 +10365,9 @@
           <a:p>
             <a:pPr>
               <a:spcBef>
-                <a:spcPts val="600"/>
+                <a:spcPts val="500"/>
               </a:spcBef>
-              <a:defRPr sz="1050" b="1">
+              <a:defRPr sz="1000" b="1">
                 <a:solidFill>
                   <a:srgbClr val="0B1F3A"/>
                 </a:solidFill>
@@ -10797,15 +10383,15 @@
                   <a:srgbClr val="1E293B"/>
                 </a:solidFill>
               </a:rPr>
-              <a:t>Audited 4,999 raw records across 6 attributes; identified and pruned 33 null transcription records (leaving 4,966 cleaned rows).</a:t>
+              <a:t>Audited 4,999 raw records across 6 attributes; identified and pruned 33 null transcription records (4,966 cleaned rows).</a:t>
             </a:r>
           </a:p>
           <a:p>
             <a:pPr>
               <a:spcBef>
-                <a:spcPts val="600"/>
+                <a:spcPts val="500"/>
               </a:spcBef>
-              <a:defRPr sz="1050" b="1">
+              <a:defRPr sz="1000" b="1">
                 <a:solidFill>
                   <a:srgbClr val="0B1F3A"/>
                 </a:solidFill>
@@ -10827,9 +10413,9 @@
           <a:p>
             <a:pPr>
               <a:spcBef>
-                <a:spcPts val="600"/>
+                <a:spcPts val="500"/>
               </a:spcBef>
-              <a:defRPr sz="1050" b="1">
+              <a:defRPr sz="1000" b="1">
                 <a:solidFill>
                   <a:srgbClr val="0B1F3A"/>
                 </a:solidFill>
@@ -10851,9 +10437,9 @@
           <a:p>
             <a:pPr>
               <a:spcBef>
-                <a:spcPts val="600"/>
+                <a:spcPts val="500"/>
               </a:spcBef>
-              <a:defRPr sz="1050" b="1">
+              <a:defRPr sz="1000" b="1">
                 <a:solidFill>
                   <a:srgbClr val="0B1F3A"/>
                 </a:solidFill>
@@ -10869,7 +10455,7 @@
                   <a:srgbClr val="1E293B"/>
                 </a:solidFill>
               </a:rPr>
-              <a:t>NO model training, NO baseline evaluation, and NO ensemble experiments were conducted in Phase 1.</a:t>
+              <a:t>NO model training, NO baseline evaluation, and NO ensemble experiments were completed in Phase 1.</a:t>
             </a:r>
           </a:p>
         </p:txBody>
@@ -10956,9 +10542,9 @@
           <a:p>
             <a:pPr>
               <a:spcBef>
-                <a:spcPts val="600"/>
+                <a:spcPts val="500"/>
               </a:spcBef>
-              <a:defRPr sz="1050" b="1">
+              <a:defRPr sz="1000" b="1">
                 <a:solidFill>
                   <a:srgbClr val="0D9488"/>
                 </a:solidFill>
@@ -10980,9 +10566,9 @@
           <a:p>
             <a:pPr>
               <a:spcBef>
-                <a:spcPts val="600"/>
+                <a:spcPts val="500"/>
               </a:spcBef>
-              <a:defRPr sz="1050" b="1">
+              <a:defRPr sz="1000" b="1">
                 <a:solidFill>
                   <a:srgbClr val="0D9488"/>
                 </a:solidFill>
@@ -11004,9 +10590,9 @@
           <a:p>
             <a:pPr>
               <a:spcBef>
-                <a:spcPts val="600"/>
+                <a:spcPts val="500"/>
               </a:spcBef>
-              <a:defRPr sz="1050" b="1">
+              <a:defRPr sz="1000" b="1">
                 <a:solidFill>
                   <a:srgbClr val="0D9488"/>
                 </a:solidFill>
@@ -11028,9 +10614,9 @@
           <a:p>
             <a:pPr>
               <a:spcBef>
-                <a:spcPts val="600"/>
+                <a:spcPts val="500"/>
               </a:spcBef>
-              <a:defRPr sz="1050" b="1">
+              <a:defRPr sz="1000" b="1">
                 <a:solidFill>
                   <a:srgbClr val="0D9488"/>
                 </a:solidFill>
@@ -11052,9 +10638,9 @@
           <a:p>
             <a:pPr>
               <a:spcBef>
-                <a:spcPts val="600"/>
+                <a:spcPts val="500"/>
               </a:spcBef>
-              <a:defRPr sz="1050" b="1">
+              <a:defRPr sz="1000" b="1">
                 <a:solidFill>
                   <a:srgbClr val="0D9488"/>
                 </a:solidFill>
@@ -11432,7 +11018,7 @@
         </p:nvGraphicFramePr>
         <p:xfrm>
           <a:off x="777240" y="1920240"/>
-          <a:ext cx="5120640" cy="3108960"/>
+          <a:ext cx="5120640" cy="3017520"/>
         </p:xfrm>
         <a:graphic>
           <a:graphicData uri="http://schemas.openxmlformats.org/drawingml/2006/table">
@@ -11444,7 +11030,7 @@
                 <a:gridCol w="3474720"/>
                 <a:gridCol w="1645920"/>
               </a:tblGrid>
-              <a:tr h="444137">
+              <a:tr h="431074">
                 <a:tc>
                   <a:txBody>
                     <a:bodyPr/>
@@ -11494,7 +11080,7 @@
                   </a:tcPr>
                 </a:tc>
               </a:tr>
-              <a:tr h="444137">
+              <a:tr h="431074">
                 <a:tc>
                   <a:txBody>
                     <a:bodyPr/>
@@ -11536,7 +11122,7 @@
                   <a:tcPr anchor="ctr"/>
                 </a:tc>
               </a:tr>
-              <a:tr h="444137">
+              <a:tr h="431074">
                 <a:tc>
                   <a:txBody>
                     <a:bodyPr/>
@@ -11578,7 +11164,7 @@
                   <a:tcPr anchor="ctr"/>
                 </a:tc>
               </a:tr>
-              <a:tr h="444137">
+              <a:tr h="431074">
                 <a:tc>
                   <a:txBody>
                     <a:bodyPr/>
@@ -11628,7 +11214,7 @@
                   </a:tcPr>
                 </a:tc>
               </a:tr>
-              <a:tr h="444137">
+              <a:tr h="431074">
                 <a:tc>
                   <a:txBody>
                     <a:bodyPr/>
@@ -11670,7 +11256,7 @@
                   <a:tcPr anchor="ctr"/>
                 </a:tc>
               </a:tr>
-              <a:tr h="444137">
+              <a:tr h="431074">
                 <a:tc>
                   <a:txBody>
                     <a:bodyPr/>
@@ -11720,7 +11306,7 @@
                   </a:tcPr>
                 </a:tc>
               </a:tr>
-              <a:tr h="444138">
+              <a:tr h="431076">
                 <a:tc>
                   <a:txBody>
                     <a:bodyPr/>
@@ -11797,7 +11383,7 @@
           <a:lstStyle/>
           <a:p>
             <a:pPr>
-              <a:defRPr sz="1000" b="1">
+              <a:defRPr sz="950" b="1">
                 <a:solidFill>
                   <a:srgbClr val="DC2626"/>
                 </a:solidFill>
@@ -12266,7 +11852,7 @@
         <p:spPr>
           <a:xfrm>
             <a:off x="548640" y="1371600"/>
-            <a:ext cx="3520440" cy="4846320"/>
+            <a:ext cx="3474720" cy="4846320"/>
           </a:xfrm>
           <a:prstGeom prst="roundRect">
             <a:avLst/>
@@ -12311,7 +11897,7 @@
         <p:spPr>
           <a:xfrm>
             <a:off x="731520" y="1554480"/>
-            <a:ext cx="3154680" cy="4480560"/>
+            <a:ext cx="3108960" cy="4480560"/>
           </a:xfrm>
           <a:prstGeom prst="rect">
             <a:avLst/>
@@ -12373,7 +11959,7 @@
             </a:r>
             <a:br/>
             <a:r>
-              <a:t>• Imbalance ratio exceeded 184:1, starving minority classes of gradient and decision updates during training.</a:t>
+              <a:t>• Imbalance ratio exceeded 184:1, starving minority classes of gradient updates during training.</a:t>
             </a:r>
           </a:p>
         </p:txBody>
@@ -12386,8 +11972,8 @@
         </p:nvSpPr>
         <p:spPr>
           <a:xfrm>
-            <a:off x="3453206545440" y="1371600"/>
-            <a:ext cx="3520440" cy="4846320"/>
+            <a:off x="4352544" y="1371600"/>
+            <a:ext cx="3474720" cy="4846320"/>
           </a:xfrm>
           <a:prstGeom prst="roundRect">
             <a:avLst/>
@@ -12431,8 +12017,8 @@
         </p:nvSpPr>
         <p:spPr>
           <a:xfrm>
-            <a:off x="3453206728320" y="1554480"/>
-            <a:ext cx="3154680" cy="4480560"/>
+            <a:off x="4535424" y="1554480"/>
+            <a:ext cx="3108960" cy="4480560"/>
           </a:xfrm>
           <a:prstGeom prst="rect">
             <a:avLst/>
@@ -12482,7 +12068,7 @@
             </a:r>
             <a:br/>
             <a:r>
-              <a:t>• Non-informative filler words and rare typographical tokens diluted diagnostic signal, crippling distance- and tree-based estimators.</a:t>
+              <a:t>• Non-informative filler words and rare typographical tokens diluted diagnostic signal, crippling estimators.</a:t>
             </a:r>
           </a:p>
         </p:txBody>
@@ -12495,8 +12081,8 @@
         </p:nvSpPr>
         <p:spPr>
           <a:xfrm>
-            <a:off x="6906412542240" y="1371600"/>
-            <a:ext cx="3520440" cy="4846320"/>
+            <a:off x="8156448" y="1371600"/>
+            <a:ext cx="3474720" cy="4846320"/>
           </a:xfrm>
           <a:prstGeom prst="roundRect">
             <a:avLst/>
@@ -12540,8 +12126,8 @@
         </p:nvSpPr>
         <p:spPr>
           <a:xfrm>
-            <a:off x="6906412725120" y="1554480"/>
-            <a:ext cx="3154680" cy="4480560"/>
+            <a:off x="8339328" y="1554480"/>
+            <a:ext cx="3108960" cy="4480560"/>
           </a:xfrm>
           <a:prstGeom prst="rect">
             <a:avLst/>
@@ -12603,7 +12189,7 @@
             </a:r>
             <a:br/>
             <a:r>
-              <a:t>• These describe document structures, not medical organ specialties, introducing overlapping vocabularies across domains.</a:t>
+              <a:t>• These describe document structures, not medical organ specialties, introducing overlapping vocabularies.</a:t>
             </a:r>
           </a:p>
         </p:txBody>
@@ -12883,7 +12469,7 @@
         <p:spPr>
           <a:xfrm>
             <a:off x="548640" y="1371600"/>
-            <a:ext cx="3520440" cy="4846320"/>
+            <a:ext cx="3474720" cy="4846320"/>
           </a:xfrm>
           <a:prstGeom prst="roundRect">
             <a:avLst/>
@@ -12928,7 +12514,7 @@
         <p:spPr>
           <a:xfrm>
             <a:off x="731520" y="1554480"/>
-            <a:ext cx="3154680" cy="4480560"/>
+            <a:ext cx="3108960" cy="4480560"/>
           </a:xfrm>
           <a:prstGeom prst="rect">
             <a:avLst/>
@@ -12987,8 +12573,8 @@
         </p:nvSpPr>
         <p:spPr>
           <a:xfrm>
-            <a:off x="3453206545440" y="1371600"/>
-            <a:ext cx="3520440" cy="4846320"/>
+            <a:off x="4352544" y="1371600"/>
+            <a:ext cx="3474720" cy="4846320"/>
           </a:xfrm>
           <a:prstGeom prst="roundRect">
             <a:avLst/>
@@ -13032,8 +12618,8 @@
         </p:nvSpPr>
         <p:spPr>
           <a:xfrm>
-            <a:off x="3453206728320" y="1554480"/>
-            <a:ext cx="3154680" cy="4480560"/>
+            <a:off x="4535424" y="1554480"/>
+            <a:ext cx="3108960" cy="4480560"/>
           </a:xfrm>
           <a:prstGeom prst="rect">
             <a:avLst/>
@@ -13096,8 +12682,8 @@
         </p:nvSpPr>
         <p:spPr>
           <a:xfrm>
-            <a:off x="6906412542240" y="1371600"/>
-            <a:ext cx="3520440" cy="4846320"/>
+            <a:off x="8156448" y="1371600"/>
+            <a:ext cx="3474720" cy="4846320"/>
           </a:xfrm>
           <a:prstGeom prst="roundRect">
             <a:avLst/>
@@ -13141,8 +12727,8 @@
         </p:nvSpPr>
         <p:spPr>
           <a:xfrm>
-            <a:off x="6906412725120" y="1554480"/>
-            <a:ext cx="3154680" cy="4480560"/>
+            <a:off x="8339328" y="1554480"/>
+            <a:ext cx="3108960" cy="4480560"/>
           </a:xfrm>
           <a:prstGeom prst="rect">
             <a:avLst/>
@@ -14299,7 +13885,7 @@
               <a:spcBef>
                 <a:spcPts val="800"/>
               </a:spcBef>
-              <a:defRPr sz="1050" b="1">
+              <a:defRPr sz="1000" b="1">
                 <a:solidFill>
                   <a:srgbClr val="0D9488"/>
                 </a:solidFill>
@@ -14323,7 +13909,7 @@
               <a:spcBef>
                 <a:spcPts val="800"/>
               </a:spcBef>
-              <a:defRPr sz="1050" b="1">
+              <a:defRPr sz="1000" b="1">
                 <a:solidFill>
                   <a:srgbClr val="0D9488"/>
                 </a:solidFill>
@@ -14347,7 +13933,7 @@
               <a:spcBef>
                 <a:spcPts val="800"/>
               </a:spcBef>
-              <a:defRPr sz="1050" b="1">
+              <a:defRPr sz="1000" b="1">
                 <a:solidFill>
                   <a:srgbClr val="0D9488"/>
                 </a:solidFill>
@@ -14371,7 +13957,7 @@
               <a:spcBef>
                 <a:spcPts val="800"/>
               </a:spcBef>
-              <a:defRPr sz="1050" b="1">
+              <a:defRPr sz="1000" b="1">
                 <a:solidFill>
                   <a:srgbClr val="0D9488"/>
                 </a:solidFill>
@@ -14740,9 +14326,9 @@
           <a:p>
             <a:pPr>
               <a:spcBef>
-                <a:spcPts val="800"/>
+                <a:spcPts val="700"/>
               </a:spcBef>
-              <a:defRPr sz="1050" b="1">
+              <a:defRPr sz="1000" b="1">
                 <a:solidFill>
                   <a:srgbClr val="0B1F3A"/>
                 </a:solidFill>
@@ -14764,9 +14350,9 @@
           <a:p>
             <a:pPr>
               <a:spcBef>
-                <a:spcPts val="800"/>
+                <a:spcPts val="700"/>
               </a:spcBef>
-              <a:defRPr sz="1050" b="1">
+              <a:defRPr sz="1000" b="1">
                 <a:solidFill>
                   <a:srgbClr val="0B1F3A"/>
                 </a:solidFill>
@@ -14788,9 +14374,9 @@
           <a:p>
             <a:pPr>
               <a:spcBef>
-                <a:spcPts val="800"/>
+                <a:spcPts val="700"/>
               </a:spcBef>
-              <a:defRPr sz="1050" b="1">
+              <a:defRPr sz="1000" b="1">
                 <a:solidFill>
                   <a:srgbClr val="0B1F3A"/>
                 </a:solidFill>
@@ -14812,9 +14398,9 @@
           <a:p>
             <a:pPr>
               <a:spcBef>
-                <a:spcPts val="800"/>
+                <a:spcPts val="700"/>
               </a:spcBef>
-              <a:defRPr sz="1050" b="1">
+              <a:defRPr sz="1000" b="1">
                 <a:solidFill>
                   <a:srgbClr val="0B1F3A"/>
                 </a:solidFill>
@@ -14836,9 +14422,9 @@
           <a:p>
             <a:pPr>
               <a:spcBef>
-                <a:spcPts val="800"/>
+                <a:spcPts val="700"/>
               </a:spcBef>
-              <a:defRPr sz="1050" b="1">
+              <a:defRPr sz="1000" b="1">
                 <a:solidFill>
                   <a:srgbClr val="0B1F3A"/>
                 </a:solidFill>
@@ -14941,9 +14527,9 @@
           <a:p>
             <a:pPr>
               <a:spcBef>
-                <a:spcPts val="600"/>
+                <a:spcPts val="500"/>
               </a:spcBef>
-              <a:defRPr sz="1050" b="1">
+              <a:defRPr sz="1000" b="1">
                 <a:solidFill>
                   <a:srgbClr val="0D9488"/>
                 </a:solidFill>
@@ -14965,9 +14551,9 @@
           <a:p>
             <a:pPr>
               <a:spcBef>
-                <a:spcPts val="600"/>
+                <a:spcPts val="500"/>
               </a:spcBef>
-              <a:defRPr sz="1050" b="1">
+              <a:defRPr sz="1000" b="1">
                 <a:solidFill>
                   <a:srgbClr val="0D9488"/>
                 </a:solidFill>
@@ -14989,9 +14575,9 @@
           <a:p>
             <a:pPr>
               <a:spcBef>
-                <a:spcPts val="600"/>
+                <a:spcPts val="500"/>
               </a:spcBef>
-              <a:defRPr sz="1050" b="1">
+              <a:defRPr sz="1000" b="1">
                 <a:solidFill>
                   <a:srgbClr val="0D9488"/>
                 </a:solidFill>
@@ -15013,9 +14599,9 @@
           <a:p>
             <a:pPr>
               <a:spcBef>
-                <a:spcPts val="600"/>
+                <a:spcPts val="500"/>
               </a:spcBef>
-              <a:defRPr sz="1050" b="1">
+              <a:defRPr sz="1000" b="1">
                 <a:solidFill>
                   <a:srgbClr val="0D9488"/>
                 </a:solidFill>
@@ -15037,9 +14623,9 @@
           <a:p>
             <a:pPr>
               <a:spcBef>
-                <a:spcPts val="600"/>
+                <a:spcPts val="500"/>
               </a:spcBef>
-              <a:defRPr sz="1050" b="1">
+              <a:defRPr sz="1000" b="1">
                 <a:solidFill>
                   <a:srgbClr val="0D9488"/>
                 </a:solidFill>
@@ -15061,9 +14647,9 @@
           <a:p>
             <a:pPr>
               <a:spcBef>
-                <a:spcPts val="600"/>
+                <a:spcPts val="500"/>
               </a:spcBef>
-              <a:defRPr sz="1050" b="1">
+              <a:defRPr sz="1000" b="1">
                 <a:solidFill>
                   <a:srgbClr val="0D9488"/>
                 </a:solidFill>
@@ -15379,7 +14965,7 @@
         <p:spPr>
           <a:xfrm>
             <a:off x="548640" y="1371600"/>
-            <a:ext cx="5394960" cy="2240280"/>
+            <a:ext cx="5394960" cy="2286000"/>
           </a:xfrm>
           <a:prstGeom prst="roundRect">
             <a:avLst/>
@@ -15424,7 +15010,7 @@
         <p:spPr>
           <a:xfrm>
             <a:off x="731520" y="1508760"/>
-            <a:ext cx="5029200" cy="1965960"/>
+            <a:ext cx="5029200" cy="2011680"/>
           </a:xfrm>
           <a:prstGeom prst="rect">
             <a:avLst/>
@@ -15488,7 +15074,7 @@
         <p:spPr>
           <a:xfrm>
             <a:off x="6217920" y="1371600"/>
-            <a:ext cx="5394960" cy="2240280"/>
+            <a:ext cx="5394960" cy="2286000"/>
           </a:xfrm>
           <a:prstGeom prst="roundRect">
             <a:avLst/>
@@ -15533,7 +15119,7 @@
         <p:spPr>
           <a:xfrm>
             <a:off x="6400800" y="1508760"/>
-            <a:ext cx="5029200" cy="1965960"/>
+            <a:ext cx="5029200" cy="2011680"/>
           </a:xfrm>
           <a:prstGeom prst="rect">
             <a:avLst/>
@@ -15592,8 +15178,8 @@
         </p:nvSpPr>
         <p:spPr>
           <a:xfrm>
-            <a:off x="548640" y="3840480"/>
-            <a:ext cx="5394960" cy="2240280"/>
+            <a:off x="548640" y="3886200"/>
+            <a:ext cx="5394960" cy="2286000"/>
           </a:xfrm>
           <a:prstGeom prst="roundRect">
             <a:avLst/>
@@ -15637,8 +15223,8 @@
         </p:nvSpPr>
         <p:spPr>
           <a:xfrm>
-            <a:off x="731520" y="3977640"/>
-            <a:ext cx="5029200" cy="1965960"/>
+            <a:off x="731520" y="4023360"/>
+            <a:ext cx="5029200" cy="2011680"/>
           </a:xfrm>
           <a:prstGeom prst="rect">
             <a:avLst/>
@@ -15693,8 +15279,8 @@
         </p:nvSpPr>
         <p:spPr>
           <a:xfrm>
-            <a:off x="6217920" y="3840480"/>
-            <a:ext cx="5394960" cy="2240280"/>
+            <a:off x="6217920" y="3886200"/>
+            <a:ext cx="5394960" cy="2286000"/>
           </a:xfrm>
           <a:prstGeom prst="roundRect">
             <a:avLst/>
@@ -15738,8 +15324,8 @@
         </p:nvSpPr>
         <p:spPr>
           <a:xfrm>
-            <a:off x="6400800" y="3977640"/>
-            <a:ext cx="5029200" cy="1965960"/>
+            <a:off x="6400800" y="4023360"/>
+            <a:ext cx="5029200" cy="2011680"/>
           </a:xfrm>
           <a:prstGeom prst="rect">
             <a:avLst/>
@@ -16061,7 +15647,7 @@
         <p:spPr>
           <a:xfrm>
             <a:off x="548640" y="1371600"/>
-            <a:ext cx="5394960" cy="2240280"/>
+            <a:ext cx="5394960" cy="2286000"/>
           </a:xfrm>
           <a:prstGeom prst="roundRect">
             <a:avLst/>
@@ -16106,7 +15692,7 @@
         <p:spPr>
           <a:xfrm>
             <a:off x="731520" y="1508760"/>
-            <a:ext cx="5029200" cy="1965960"/>
+            <a:ext cx="5029200" cy="2011680"/>
           </a:xfrm>
           <a:prstGeom prst="rect">
             <a:avLst/>
@@ -16182,7 +15768,7 @@
         <p:spPr>
           <a:xfrm>
             <a:off x="6217920" y="1371600"/>
-            <a:ext cx="5394960" cy="2240280"/>
+            <a:ext cx="5394960" cy="2286000"/>
           </a:xfrm>
           <a:prstGeom prst="roundRect">
             <a:avLst/>
@@ -16227,7 +15813,7 @@
         <p:spPr>
           <a:xfrm>
             <a:off x="6400800" y="1508760"/>
-            <a:ext cx="5029200" cy="1965960"/>
+            <a:ext cx="5029200" cy="2011680"/>
           </a:xfrm>
           <a:prstGeom prst="rect">
             <a:avLst/>
@@ -16302,8 +15888,8 @@
         </p:nvSpPr>
         <p:spPr>
           <a:xfrm>
-            <a:off x="548640" y="3840480"/>
-            <a:ext cx="5394960" cy="2240280"/>
+            <a:off x="548640" y="3886200"/>
+            <a:ext cx="5394960" cy="2286000"/>
           </a:xfrm>
           <a:prstGeom prst="roundRect">
             <a:avLst/>
@@ -16347,8 +15933,8 @@
         </p:nvSpPr>
         <p:spPr>
           <a:xfrm>
-            <a:off x="731520" y="3977640"/>
-            <a:ext cx="5029200" cy="1965960"/>
+            <a:off x="731520" y="4023360"/>
+            <a:ext cx="5029200" cy="2011680"/>
           </a:xfrm>
           <a:prstGeom prst="rect">
             <a:avLst/>
@@ -16423,8 +16009,8 @@
         </p:nvSpPr>
         <p:spPr>
           <a:xfrm>
-            <a:off x="6217920" y="3840480"/>
-            <a:ext cx="5394960" cy="2240280"/>
+            <a:off x="6217920" y="3886200"/>
+            <a:ext cx="5394960" cy="2286000"/>
           </a:xfrm>
           <a:prstGeom prst="roundRect">
             <a:avLst/>
@@ -16468,8 +16054,8 @@
         </p:nvSpPr>
         <p:spPr>
           <a:xfrm>
-            <a:off x="6400800" y="3977640"/>
-            <a:ext cx="5029200" cy="1965960"/>
+            <a:off x="6400800" y="4023360"/>
+            <a:ext cx="5029200" cy="2011680"/>
           </a:xfrm>
           <a:prstGeom prst="rect">
             <a:avLst/>

</xml_diff>